<commit_message>
Refine submission materials and stabilize web navigation
</commit_message>
<xml_diff>
--- a/docs/competition/ic/technical_report/presentation/ICARUS_答辩材料.pptx
+++ b/docs/competition/ic/technical_report/presentation/ICARUS_答辩材料.pptx
@@ -466,7 +466,7 @@
           </a:p>
           <a:p xmlns:a="http://schemas.openxmlformats.org/drawingml/2006/main">
             <a:r>
-              <a:t>SHA-256：f108fcf001dbd7c40278822151d4ed785065b96eb8ea7209443e34afb5787792</a:t>
+              <a:t>SHA-256：516d745799a82998d874813a968d9df036b342924485b4128bf3bd5ac0d7fdd2</a:t>
             </a:r>
           </a:p>
           <a:p xmlns:a="http://schemas.openxmlformats.org/drawingml/2006/main">
@@ -581,7 +581,7 @@
           </a:p>
           <a:p xmlns:a="http://schemas.openxmlformats.org/drawingml/2006/main">
             <a:r>
-              <a:t>SHA-256：f108fcf001dbd7c40278822151d4ed785065b96eb8ea7209443e34afb5787792</a:t>
+              <a:t>SHA-256：516d745799a82998d874813a968d9df036b342924485b4128bf3bd5ac0d7fdd2</a:t>
             </a:r>
           </a:p>
           <a:p xmlns:a="http://schemas.openxmlformats.org/drawingml/2006/main">
@@ -696,7 +696,7 @@
           </a:p>
           <a:p xmlns:a="http://schemas.openxmlformats.org/drawingml/2006/main">
             <a:r>
-              <a:t>SHA-256：f108fcf001dbd7c40278822151d4ed785065b96eb8ea7209443e34afb5787792</a:t>
+              <a:t>SHA-256：516d745799a82998d874813a968d9df036b342924485b4128bf3bd5ac0d7fdd2</a:t>
             </a:r>
           </a:p>
           <a:p xmlns:a="http://schemas.openxmlformats.org/drawingml/2006/main">
@@ -811,7 +811,7 @@
           </a:p>
           <a:p xmlns:a="http://schemas.openxmlformats.org/drawingml/2006/main">
             <a:r>
-              <a:t>SHA-256：f108fcf001dbd7c40278822151d4ed785065b96eb8ea7209443e34afb5787792</a:t>
+              <a:t>SHA-256：516d745799a82998d874813a968d9df036b342924485b4128bf3bd5ac0d7fdd2</a:t>
             </a:r>
           </a:p>
           <a:p xmlns:a="http://schemas.openxmlformats.org/drawingml/2006/main">
@@ -936,7 +936,7 @@
           </a:p>
           <a:p xmlns:a="http://schemas.openxmlformats.org/drawingml/2006/main">
             <a:r>
-              <a:t>SHA-256：f108fcf001dbd7c40278822151d4ed785065b96eb8ea7209443e34afb5787792</a:t>
+              <a:t>SHA-256：516d745799a82998d874813a968d9df036b342924485b4128bf3bd5ac0d7fdd2</a:t>
             </a:r>
           </a:p>
           <a:p xmlns:a="http://schemas.openxmlformats.org/drawingml/2006/main">
@@ -1051,7 +1051,7 @@
           </a:p>
           <a:p xmlns:a="http://schemas.openxmlformats.org/drawingml/2006/main">
             <a:r>
-              <a:t>SHA-256：f108fcf001dbd7c40278822151d4ed785065b96eb8ea7209443e34afb5787792</a:t>
+              <a:t>SHA-256：516d745799a82998d874813a968d9df036b342924485b4128bf3bd5ac0d7fdd2</a:t>
             </a:r>
           </a:p>
           <a:p xmlns:a="http://schemas.openxmlformats.org/drawingml/2006/main">
@@ -1176,7 +1176,7 @@
           </a:p>
           <a:p xmlns:a="http://schemas.openxmlformats.org/drawingml/2006/main">
             <a:r>
-              <a:t>SHA-256：f108fcf001dbd7c40278822151d4ed785065b96eb8ea7209443e34afb5787792</a:t>
+              <a:t>SHA-256：516d745799a82998d874813a968d9df036b342924485b4128bf3bd5ac0d7fdd2</a:t>
             </a:r>
           </a:p>
           <a:p xmlns:a="http://schemas.openxmlformats.org/drawingml/2006/main">
@@ -1301,7 +1301,7 @@
           </a:p>
           <a:p xmlns:a="http://schemas.openxmlformats.org/drawingml/2006/main">
             <a:r>
-              <a:t>SHA-256：f108fcf001dbd7c40278822151d4ed785065b96eb8ea7209443e34afb5787792</a:t>
+              <a:t>SHA-256：516d745799a82998d874813a968d9df036b342924485b4128bf3bd5ac0d7fdd2</a:t>
             </a:r>
           </a:p>
           <a:p xmlns:a="http://schemas.openxmlformats.org/drawingml/2006/main">
@@ -1416,7 +1416,7 @@
           </a:p>
           <a:p xmlns:a="http://schemas.openxmlformats.org/drawingml/2006/main">
             <a:r>
-              <a:t>SHA-256：f108fcf001dbd7c40278822151d4ed785065b96eb8ea7209443e34afb5787792</a:t>
+              <a:t>SHA-256：516d745799a82998d874813a968d9df036b342924485b4128bf3bd5ac0d7fdd2</a:t>
             </a:r>
           </a:p>
           <a:p xmlns:a="http://schemas.openxmlformats.org/drawingml/2006/main">
@@ -1531,7 +1531,7 @@
           </a:p>
           <a:p xmlns:a="http://schemas.openxmlformats.org/drawingml/2006/main">
             <a:r>
-              <a:t>SHA-256：f108fcf001dbd7c40278822151d4ed785065b96eb8ea7209443e34afb5787792</a:t>
+              <a:t>SHA-256：516d745799a82998d874813a968d9df036b342924485b4128bf3bd5ac0d7fdd2</a:t>
             </a:r>
           </a:p>
           <a:p xmlns:a="http://schemas.openxmlformats.org/drawingml/2006/main">
@@ -1646,7 +1646,7 @@
           </a:p>
           <a:p xmlns:a="http://schemas.openxmlformats.org/drawingml/2006/main">
             <a:r>
-              <a:t>SHA-256：f108fcf001dbd7c40278822151d4ed785065b96eb8ea7209443e34afb5787792</a:t>
+              <a:t>SHA-256：516d745799a82998d874813a968d9df036b342924485b4128bf3bd5ac0d7fdd2</a:t>
             </a:r>
           </a:p>
           <a:p xmlns:a="http://schemas.openxmlformats.org/drawingml/2006/main">
@@ -1761,7 +1761,7 @@
           </a:p>
           <a:p xmlns:a="http://schemas.openxmlformats.org/drawingml/2006/main">
             <a:r>
-              <a:t>SHA-256：f108fcf001dbd7c40278822151d4ed785065b96eb8ea7209443e34afb5787792</a:t>
+              <a:t>SHA-256：516d745799a82998d874813a968d9df036b342924485b4128bf3bd5ac0d7fdd2</a:t>
             </a:r>
           </a:p>
           <a:p xmlns:a="http://schemas.openxmlformats.org/drawingml/2006/main">
@@ -1876,7 +1876,7 @@
           </a:p>
           <a:p xmlns:a="http://schemas.openxmlformats.org/drawingml/2006/main">
             <a:r>
-              <a:t>SHA-256：f108fcf001dbd7c40278822151d4ed785065b96eb8ea7209443e34afb5787792</a:t>
+              <a:t>SHA-256：516d745799a82998d874813a968d9df036b342924485b4128bf3bd5ac0d7fdd2</a:t>
             </a:r>
           </a:p>
           <a:p xmlns:a="http://schemas.openxmlformats.org/drawingml/2006/main">
@@ -2001,7 +2001,7 @@
           </a:p>
           <a:p xmlns:a="http://schemas.openxmlformats.org/drawingml/2006/main">
             <a:r>
-              <a:t>SHA-256：f108fcf001dbd7c40278822151d4ed785065b96eb8ea7209443e34afb5787792</a:t>
+              <a:t>SHA-256：516d745799a82998d874813a968d9df036b342924485b4128bf3bd5ac0d7fdd2</a:t>
             </a:r>
           </a:p>
           <a:p xmlns:a="http://schemas.openxmlformats.org/drawingml/2006/main">
@@ -2116,7 +2116,7 @@
           </a:p>
           <a:p xmlns:a="http://schemas.openxmlformats.org/drawingml/2006/main">
             <a:r>
-              <a:t>SHA-256：f108fcf001dbd7c40278822151d4ed785065b96eb8ea7209443e34afb5787792</a:t>
+              <a:t>SHA-256：516d745799a82998d874813a968d9df036b342924485b4128bf3bd5ac0d7fdd2</a:t>
             </a:r>
           </a:p>
           <a:p xmlns:a="http://schemas.openxmlformats.org/drawingml/2006/main">
@@ -2231,7 +2231,7 @@
           </a:p>
           <a:p xmlns:a="http://schemas.openxmlformats.org/drawingml/2006/main">
             <a:r>
-              <a:t>SHA-256：f108fcf001dbd7c40278822151d4ed785065b96eb8ea7209443e34afb5787792</a:t>
+              <a:t>SHA-256：516d745799a82998d874813a968d9df036b342924485b4128bf3bd5ac0d7fdd2</a:t>
             </a:r>
           </a:p>
           <a:p xmlns:a="http://schemas.openxmlformats.org/drawingml/2006/main">
@@ -2346,7 +2346,7 @@
           </a:p>
           <a:p xmlns:a="http://schemas.openxmlformats.org/drawingml/2006/main">
             <a:r>
-              <a:t>SHA-256：f108fcf001dbd7c40278822151d4ed785065b96eb8ea7209443e34afb5787792</a:t>
+              <a:t>SHA-256：516d745799a82998d874813a968d9df036b342924485b4128bf3bd5ac0d7fdd2</a:t>
             </a:r>
           </a:p>
           <a:p xmlns:a="http://schemas.openxmlformats.org/drawingml/2006/main">
@@ -2461,7 +2461,7 @@
           </a:p>
           <a:p xmlns:a="http://schemas.openxmlformats.org/drawingml/2006/main">
             <a:r>
-              <a:t>SHA-256：f108fcf001dbd7c40278822151d4ed785065b96eb8ea7209443e34afb5787792</a:t>
+              <a:t>SHA-256：516d745799a82998d874813a968d9df036b342924485b4128bf3bd5ac0d7fdd2</a:t>
             </a:r>
           </a:p>
           <a:p xmlns:a="http://schemas.openxmlformats.org/drawingml/2006/main">
@@ -2586,7 +2586,7 @@
           </a:p>
           <a:p xmlns:a="http://schemas.openxmlformats.org/drawingml/2006/main">
             <a:r>
-              <a:t>SHA-256：f108fcf001dbd7c40278822151d4ed785065b96eb8ea7209443e34afb5787792</a:t>
+              <a:t>SHA-256：516d745799a82998d874813a968d9df036b342924485b4128bf3bd5ac0d7fdd2</a:t>
             </a:r>
           </a:p>
           <a:p xmlns:a="http://schemas.openxmlformats.org/drawingml/2006/main">
@@ -2701,7 +2701,7 @@
           </a:p>
           <a:p xmlns:a="http://schemas.openxmlformats.org/drawingml/2006/main">
             <a:r>
-              <a:t>SHA-256：f108fcf001dbd7c40278822151d4ed785065b96eb8ea7209443e34afb5787792</a:t>
+              <a:t>SHA-256：516d745799a82998d874813a968d9df036b342924485b4128bf3bd5ac0d7fdd2</a:t>
             </a:r>
           </a:p>
           <a:p xmlns:a="http://schemas.openxmlformats.org/drawingml/2006/main">

</xml_diff>